<commit_message>
Deployed dcafed0 with MkDocs version: 1.6.1
</commit_message>
<xml_diff>
--- a/pdfs/Brasseur_lecon_5juin.pptx
+++ b/pdfs/Brasseur_lecon_5juin.pptx
@@ -3293,6 +3293,41 @@
                 </a:solidFill>
                 <a:latin typeface="Helvetica"/>
               </a:rPr>
+              <a:t>Trois défis structurels pour les futur·es travailleur·euses sociaux·ales</a:t>
+            </a:r>
+          </a:p>
+        </p:txBody>
+      </p:sp>
+      <p:sp>
+        <p:nvSpPr>
+          <p:cNvPr id="7" name="TextBox 6"/>
+          <p:cNvSpPr txBox="1"/>
+          <p:nvPr/>
+        </p:nvSpPr>
+        <p:spPr>
+          <a:xfrm>
+            <a:off x="731520" y="3108960"/>
+            <a:ext cx="10698480" cy="457200"/>
+          </a:xfrm>
+          <a:prstGeom prst="rect">
+            <a:avLst/>
+          </a:prstGeom>
+          <a:noFill/>
+        </p:spPr>
+        <p:txBody>
+          <a:bodyPr wrap="square" anchor="t" lIns="0" rIns="0" tIns="0" bIns="0">
+            <a:spAutoFit/>
+          </a:bodyPr>
+          <a:lstStyle/>
+          <a:p>
+            <a:pPr algn="l"/>
+            <a:r>
+              <a:rPr sz="1500" b="0" i="1">
+                <a:solidFill>
+                  <a:srgbClr val="FFFFFF"/>
+                </a:solidFill>
+                <a:latin typeface="Helvetica"/>
+              </a:rPr>
               <a:t>Transformations du champ du handicap et nouvelle posture du travail social</a:t>
             </a:r>
           </a:p>
@@ -3300,7 +3335,7 @@
       </p:sp>
       <p:sp>
         <p:nvSpPr>
-          <p:cNvPr id="7" name="TextBox 6"/>
+          <p:cNvPr id="8" name="TextBox 7"/>
           <p:cNvSpPr txBox="1"/>
           <p:nvPr/>
         </p:nvSpPr>
@@ -3335,7 +3370,7 @@
       </p:sp>
       <p:sp>
         <p:nvSpPr>
-          <p:cNvPr id="8" name="TextBox 7"/>
+          <p:cNvPr id="9" name="TextBox 8"/>
           <p:cNvSpPr txBox="1"/>
           <p:nvPr/>
         </p:nvSpPr>
@@ -3370,7 +3405,7 @@
       </p:sp>
       <p:sp>
         <p:nvSpPr>
-          <p:cNvPr id="9" name="TextBox 8"/>
+          <p:cNvPr id="10" name="TextBox 9"/>
           <p:cNvSpPr txBox="1"/>
           <p:nvPr/>
         </p:nvSpPr>
@@ -5061,7 +5096,7 @@
                 </a:solidFill>
                 <a:latin typeface="Helvetica"/>
               </a:rPr>
-              <a:t>Tension 1 : protection / autonomie</a:t>
+              <a:t>Défi 1 — protection / autonomie</a:t>
             </a:r>
           </a:p>
         </p:txBody>
@@ -5696,7 +5731,7 @@
                 </a:solidFill>
                 <a:latin typeface="Helvetica"/>
               </a:rPr>
-              <a:t>Du protégé au sujet de droits · Leçon probatoire HETS · 5 juin 2026 · Tension 1</a:t>
+              <a:t>Du protégé au sujet de droits · Leçon probatoire HETS · 5 juin 2026 · Défi 1</a:t>
             </a:r>
           </a:p>
         </p:txBody>
@@ -5828,7 +5863,7 @@
                 </a:solidFill>
                 <a:latin typeface="Helvetica"/>
               </a:rPr>
-              <a:t>Tension 2 : expertise professionnelle / savoir expérientiel</a:t>
+              <a:t>Défi 2 — expertise professionnelle / savoir expérientiel</a:t>
             </a:r>
           </a:p>
         </p:txBody>
@@ -6463,7 +6498,7 @@
                 </a:solidFill>
                 <a:latin typeface="Helvetica"/>
               </a:rPr>
-              <a:t>Du protégé au sujet de droits · Leçon probatoire HETS · 5 juin 2026 · Tension 2</a:t>
+              <a:t>Du protégé au sujet de droits · Leçon probatoire HETS · 5 juin 2026 · Défi 2</a:t>
             </a:r>
           </a:p>
         </p:txBody>
@@ -6595,7 +6630,7 @@
                 </a:solidFill>
                 <a:latin typeface="Helvetica"/>
               </a:rPr>
-              <a:t>Tension 3 : travail prescrit / travail réel</a:t>
+              <a:t>Défi 3 — travail prescrit / travail réel</a:t>
             </a:r>
           </a:p>
         </p:txBody>
@@ -7230,7 +7265,7 @@
                 </a:solidFill>
                 <a:latin typeface="Helvetica"/>
               </a:rPr>
-              <a:t>Du protégé au sujet de droits · Leçon probatoire HETS · 5 juin 2026 · Tension 3</a:t>
+              <a:t>Du protégé au sujet de droits · Leçon probatoire HETS · 5 juin 2026 · Défi 3</a:t>
             </a:r>
           </a:p>
         </p:txBody>
@@ -7570,7 +7605,7 @@
                 </a:solidFill>
                 <a:latin typeface="Helvetica"/>
               </a:rPr>
-              <a:t>1. Seul·e, 2 minutes : choisis une des trois tensions.</a:t>
+              <a:t>1. Seul·e, 2 minutes : choisis l'un des trois défis structurels.</a:t>
             </a:r>
           </a:p>
           <a:p>
@@ -7594,7 +7629,7 @@
                 </a:solidFill>
                 <a:latin typeface="Helvetica"/>
               </a:rPr>
-              <a:t>3. Restitution rapide : 3 binômes, un par tension. Pas de « bonne réponse » — une posture argumentée.</a:t>
+              <a:t>3. Restitution rapide : 3 binômes, un par défi. Pas de « bonne réponse » — une posture argumentée.</a:t>
             </a:r>
           </a:p>
         </p:txBody>
@@ -8111,7 +8146,7 @@
                 </a:solidFill>
                 <a:latin typeface="Helvetica"/>
               </a:rPr>
-              <a:t>C'est un travail réflexif quotidien sur trois tensions structurelles : protection/autonomie, expertise/expérience, prescrit/réel.</a:t>
+              <a:t>C'est un travail réflexif quotidien sur trois défis structurels (tensions) : protection/autonomie, expertise/expérience, prescrit/réel.</a:t>
             </a:r>
           </a:p>
         </p:txBody>
@@ -9681,7 +9716,7 @@
                 </a:solidFill>
                 <a:latin typeface="Helvetica"/>
               </a:rPr>
-              <a:t>Trois tensions de la pratique professionnelle</a:t>
+              <a:t>Trois défis structurels (tensions) de la pratique professionnelle</a:t>
             </a:r>
           </a:p>
         </p:txBody>

</xml_diff>